<commit_message>
Update presentation and results with mBERT full model performance metrics
</commit_message>
<xml_diff>
--- a/presentation/Multilingual_Toxic_Classification.pptx
+++ b/presentation/Multilingual_Toxic_Classification.pptx
@@ -256,6 +256,17 @@
             <c:bubble3D val="0"/>
             <c:spPr>
               <a:solidFill>
+                <a:srgbClr val="028090"/>
+              </a:solidFill>
+              <a:effectLst/>
+            </c:spPr>
+          </c:dPt>
+          <c:dPt>
+            <c:idx val="5"/>
+            <c:invertIfNegative val="0"/>
+            <c:bubble3D val="0"/>
+            <c:spPr>
+              <a:solidFill>
                 <a:srgbClr val="00A896"/>
               </a:solidFill>
               <a:effectLst/>
@@ -263,9 +274,9 @@
           </c:dPt>
           <c:cat>
             <c:multiLvlStrRef>
-              <c:f>Sheet1!$A$2:$A$6</c:f>
+              <c:f>Sheet1!$A$2:$A$7</c:f>
               <c:multiLvlStrCache>
-                <c:ptCount val="5"/>
+                <c:ptCount val="6"/>
                 <c:lvl>
                   <c:pt idx="0">
                     <c:v>LogReg</c:v>
@@ -280,6 +291,9 @@
                     <c:v>BiLSTM</c:v>
                   </c:pt>
                   <c:pt idx="4">
+                    <c:v>mBERT full</c:v>
+                  </c:pt>
+                  <c:pt idx="5">
                     <c:v>mBERT+Adapter</c:v>
                   </c:pt>
                 </c:lvl>
@@ -288,10 +302,10 @@
           </c:cat>
           <c:val>
             <c:numRef>
-              <c:f>Sheet1!$B$2:$B$6</c:f>
+              <c:f>Sheet1!$B$2:$B$7</c:f>
               <c:numCache>
                 <c:formatCode>General</c:formatCode>
-                <c:ptCount val="5"/>
+                <c:ptCount val="6"/>
                 <c:pt idx="0">
                   <c:v>0.627</c:v>
                 </c:pt>
@@ -305,6 +319,9 @@
                   <c:v>0.601</c:v>
                 </c:pt>
                 <c:pt idx="4">
+                  <c:v>0.848</c:v>
+                </c:pt>
+                <c:pt idx="5">
                   <c:v>0.826</c:v>
                 </c:pt>
               </c:numCache>
@@ -7528,7 +7545,7 @@
                 <a:ea typeface="Georgia" pitchFamily="34" charset="-122"/>
                 <a:cs typeface="Georgia" pitchFamily="34" charset="-120"/>
               </a:rPr>
-              <a:t>~15%</a:t>
+              <a:t>~10%</a:t>
             </a:r>
             <a:endParaRPr lang="en-US" sz="3600" dirty="0"/>
           </a:p>
@@ -13904,7 +13921,7 @@
                 <a:gridCol w="1463040"/>
                 <a:gridCol w="1051560"/>
               </a:tblGrid>
-              <a:tr h="475488">
+              <a:tr h="402336">
                 <a:tc>
                   <a:txBody>
                     <a:bodyPr/>
@@ -14178,7 +14195,7 @@
                   </a:tcPr>
                 </a:tc>
               </a:tr>
-              <a:tr h="475488">
+              <a:tr h="402336">
                 <a:tc>
                   <a:txBody>
                     <a:bodyPr/>
@@ -14452,7 +14469,7 @@
                   </a:tcPr>
                 </a:tc>
               </a:tr>
-              <a:tr h="475488">
+              <a:tr h="402336">
                 <a:tc>
                   <a:txBody>
                     <a:bodyPr/>
@@ -14726,7 +14743,7 @@
                   </a:tcPr>
                 </a:tc>
               </a:tr>
-              <a:tr h="475488">
+              <a:tr h="402336">
                 <a:tc>
                   <a:txBody>
                     <a:bodyPr/>
@@ -15000,7 +15017,7 @@
                   </a:tcPr>
                 </a:tc>
               </a:tr>
-              <a:tr h="475488">
+              <a:tr h="402336">
                 <a:tc>
                   <a:txBody>
                     <a:bodyPr/>
@@ -15274,7 +15291,281 @@
                   </a:tcPr>
                 </a:tc>
               </a:tr>
-              <a:tr h="475488">
+              <a:tr h="402336">
+                <a:tc>
+                  <a:txBody>
+                    <a:bodyPr/>
+                    <a:lstStyle/>
+                    <a:p>
+                      <a:pPr algn="l" indent="0" marL="0">
+                        <a:buNone/>
+                      </a:pPr>
+                      <a:r>
+                        <a:rPr lang="en-US" sz="1400" dirty="0">
+                          <a:solidFill>
+                            <a:srgbClr val="243044"/>
+                          </a:solidFill>
+                          <a:latin typeface="Calibri" pitchFamily="34" charset="0"/>
+                          <a:ea typeface="Calibri" pitchFamily="34" charset="-122"/>
+                          <a:cs typeface="Calibri" pitchFamily="34" charset="-120"/>
+                        </a:rPr>
+                        <a:t>mBERT (full)</a:t>
+                      </a:r>
+                      <a:endParaRPr lang="en-US" sz="1400" dirty="0">
+                        <a:latin typeface="Calibri" charset="0"/>
+                        <a:ea typeface="Calibri" charset="0"/>
+                        <a:cs typeface="Calibri" charset="0"/>
+                      </a:endParaRPr>
+                    </a:p>
+                  </a:txBody>
+                  <a:tcPr marL="91440" marR="91440" marT="45720" marB="45720" anchor="ctr">
+                    <a:lnL w="12700" cap="flat" cmpd="sng" algn="ctr">
+                      <a:solidFill>
+                        <a:srgbClr val="D5DEEA"/>
+                      </a:solidFill>
+                      <a:prstDash val="solid"/>
+                      <a:round/>
+                      <a:headEnd type="none" w="med" len="med"/>
+                      <a:tailEnd type="none" w="med" len="med"/>
+                    </a:lnL>
+                    <a:lnR w="12700" cap="flat" cmpd="sng" algn="ctr">
+                      <a:solidFill>
+                        <a:srgbClr val="D5DEEA"/>
+                      </a:solidFill>
+                      <a:prstDash val="solid"/>
+                      <a:round/>
+                      <a:headEnd type="none" w="med" len="med"/>
+                      <a:tailEnd type="none" w="med" len="med"/>
+                    </a:lnR>
+                    <a:lnT w="12700" cap="flat" cmpd="sng" algn="ctr">
+                      <a:solidFill>
+                        <a:srgbClr val="D5DEEA"/>
+                      </a:solidFill>
+                      <a:prstDash val="solid"/>
+                      <a:round/>
+                      <a:headEnd type="none" w="med" len="med"/>
+                      <a:tailEnd type="none" w="med" len="med"/>
+                    </a:lnT>
+                    <a:lnB w="12700" cap="flat" cmpd="sng" algn="ctr">
+                      <a:solidFill>
+                        <a:srgbClr val="D5DEEA"/>
+                      </a:solidFill>
+                      <a:prstDash val="solid"/>
+                      <a:round/>
+                      <a:headEnd type="none" w="med" len="med"/>
+                      <a:tailEnd type="none" w="med" len="med"/>
+                    </a:lnB>
+                    <a:solidFill>
+                      <a:srgbClr val="FFFFFF"/>
+                    </a:solidFill>
+                  </a:tcPr>
+                </a:tc>
+                <a:tc>
+                  <a:txBody>
+                    <a:bodyPr/>
+                    <a:lstStyle/>
+                    <a:p>
+                      <a:pPr algn="ctr" indent="0" marL="0">
+                        <a:buNone/>
+                      </a:pPr>
+                      <a:r>
+                        <a:rPr lang="en-US" sz="1400" dirty="0">
+                          <a:solidFill>
+                            <a:srgbClr val="243044"/>
+                          </a:solidFill>
+                          <a:latin typeface="Calibri" pitchFamily="34" charset="0"/>
+                          <a:ea typeface="Calibri" pitchFamily="34" charset="-122"/>
+                          <a:cs typeface="Calibri" pitchFamily="34" charset="-120"/>
+                        </a:rPr>
+                        <a:t>0.961</a:t>
+                      </a:r>
+                      <a:endParaRPr lang="en-US" sz="1400" dirty="0">
+                        <a:latin typeface="Calibri" charset="0"/>
+                        <a:ea typeface="Calibri" charset="0"/>
+                        <a:cs typeface="Calibri" charset="0"/>
+                      </a:endParaRPr>
+                    </a:p>
+                  </a:txBody>
+                  <a:tcPr marL="91440" marR="91440" marT="45720" marB="45720" anchor="ctr">
+                    <a:lnL w="12700" cap="flat" cmpd="sng" algn="ctr">
+                      <a:solidFill>
+                        <a:srgbClr val="D5DEEA"/>
+                      </a:solidFill>
+                      <a:prstDash val="solid"/>
+                      <a:round/>
+                      <a:headEnd type="none" w="med" len="med"/>
+                      <a:tailEnd type="none" w="med" len="med"/>
+                    </a:lnL>
+                    <a:lnR w="12700" cap="flat" cmpd="sng" algn="ctr">
+                      <a:solidFill>
+                        <a:srgbClr val="D5DEEA"/>
+                      </a:solidFill>
+                      <a:prstDash val="solid"/>
+                      <a:round/>
+                      <a:headEnd type="none" w="med" len="med"/>
+                      <a:tailEnd type="none" w="med" len="med"/>
+                    </a:lnR>
+                    <a:lnT w="12700" cap="flat" cmpd="sng" algn="ctr">
+                      <a:solidFill>
+                        <a:srgbClr val="D5DEEA"/>
+                      </a:solidFill>
+                      <a:prstDash val="solid"/>
+                      <a:round/>
+                      <a:headEnd type="none" w="med" len="med"/>
+                      <a:tailEnd type="none" w="med" len="med"/>
+                    </a:lnT>
+                    <a:lnB w="12700" cap="flat" cmpd="sng" algn="ctr">
+                      <a:solidFill>
+                        <a:srgbClr val="D5DEEA"/>
+                      </a:solidFill>
+                      <a:prstDash val="solid"/>
+                      <a:round/>
+                      <a:headEnd type="none" w="med" len="med"/>
+                      <a:tailEnd type="none" w="med" len="med"/>
+                    </a:lnB>
+                    <a:solidFill>
+                      <a:srgbClr val="FFFFFF"/>
+                    </a:solidFill>
+                  </a:tcPr>
+                </a:tc>
+                <a:tc>
+                  <a:txBody>
+                    <a:bodyPr/>
+                    <a:lstStyle/>
+                    <a:p>
+                      <a:pPr algn="ctr" indent="0" marL="0">
+                        <a:buNone/>
+                      </a:pPr>
+                      <a:r>
+                        <a:rPr lang="en-US" sz="1400" dirty="0">
+                          <a:solidFill>
+                            <a:srgbClr val="243044"/>
+                          </a:solidFill>
+                          <a:latin typeface="Calibri" pitchFamily="34" charset="0"/>
+                          <a:ea typeface="Calibri" pitchFamily="34" charset="-122"/>
+                          <a:cs typeface="Calibri" pitchFamily="34" charset="-120"/>
+                        </a:rPr>
+                        <a:t>0.848</a:t>
+                      </a:r>
+                      <a:endParaRPr lang="en-US" sz="1400" dirty="0">
+                        <a:latin typeface="Calibri" charset="0"/>
+                        <a:ea typeface="Calibri" charset="0"/>
+                        <a:cs typeface="Calibri" charset="0"/>
+                      </a:endParaRPr>
+                    </a:p>
+                  </a:txBody>
+                  <a:tcPr marL="91440" marR="91440" marT="45720" marB="45720" anchor="ctr">
+                    <a:lnL w="12700" cap="flat" cmpd="sng" algn="ctr">
+                      <a:solidFill>
+                        <a:srgbClr val="D5DEEA"/>
+                      </a:solidFill>
+                      <a:prstDash val="solid"/>
+                      <a:round/>
+                      <a:headEnd type="none" w="med" len="med"/>
+                      <a:tailEnd type="none" w="med" len="med"/>
+                    </a:lnL>
+                    <a:lnR w="12700" cap="flat" cmpd="sng" algn="ctr">
+                      <a:solidFill>
+                        <a:srgbClr val="D5DEEA"/>
+                      </a:solidFill>
+                      <a:prstDash val="solid"/>
+                      <a:round/>
+                      <a:headEnd type="none" w="med" len="med"/>
+                      <a:tailEnd type="none" w="med" len="med"/>
+                    </a:lnR>
+                    <a:lnT w="12700" cap="flat" cmpd="sng" algn="ctr">
+                      <a:solidFill>
+                        <a:srgbClr val="D5DEEA"/>
+                      </a:solidFill>
+                      <a:prstDash val="solid"/>
+                      <a:round/>
+                      <a:headEnd type="none" w="med" len="med"/>
+                      <a:tailEnd type="none" w="med" len="med"/>
+                    </a:lnT>
+                    <a:lnB w="12700" cap="flat" cmpd="sng" algn="ctr">
+                      <a:solidFill>
+                        <a:srgbClr val="D5DEEA"/>
+                      </a:solidFill>
+                      <a:prstDash val="solid"/>
+                      <a:round/>
+                      <a:headEnd type="none" w="med" len="med"/>
+                      <a:tailEnd type="none" w="med" len="med"/>
+                    </a:lnB>
+                    <a:solidFill>
+                      <a:srgbClr val="FFFFFF"/>
+                    </a:solidFill>
+                  </a:tcPr>
+                </a:tc>
+                <a:tc>
+                  <a:txBody>
+                    <a:bodyPr/>
+                    <a:lstStyle/>
+                    <a:p>
+                      <a:pPr algn="ctr" indent="0" marL="0">
+                        <a:buNone/>
+                      </a:pPr>
+                      <a:r>
+                        <a:rPr lang="en-US" sz="1400" dirty="0">
+                          <a:solidFill>
+                            <a:srgbClr val="243044"/>
+                          </a:solidFill>
+                          <a:latin typeface="Calibri" pitchFamily="34" charset="0"/>
+                          <a:ea typeface="Calibri" pitchFamily="34" charset="-122"/>
+                          <a:cs typeface="Calibri" pitchFamily="34" charset="-120"/>
+                        </a:rPr>
+                        <a:t>100%</a:t>
+                      </a:r>
+                      <a:endParaRPr lang="en-US" sz="1400" dirty="0">
+                        <a:latin typeface="Calibri" charset="0"/>
+                        <a:ea typeface="Calibri" charset="0"/>
+                        <a:cs typeface="Calibri" charset="0"/>
+                      </a:endParaRPr>
+                    </a:p>
+                  </a:txBody>
+                  <a:tcPr marL="91440" marR="91440" marT="45720" marB="45720" anchor="ctr">
+                    <a:lnL w="12700" cap="flat" cmpd="sng" algn="ctr">
+                      <a:solidFill>
+                        <a:srgbClr val="D5DEEA"/>
+                      </a:solidFill>
+                      <a:prstDash val="solid"/>
+                      <a:round/>
+                      <a:headEnd type="none" w="med" len="med"/>
+                      <a:tailEnd type="none" w="med" len="med"/>
+                    </a:lnL>
+                    <a:lnR w="12700" cap="flat" cmpd="sng" algn="ctr">
+                      <a:solidFill>
+                        <a:srgbClr val="D5DEEA"/>
+                      </a:solidFill>
+                      <a:prstDash val="solid"/>
+                      <a:round/>
+                      <a:headEnd type="none" w="med" len="med"/>
+                      <a:tailEnd type="none" w="med" len="med"/>
+                    </a:lnR>
+                    <a:lnT w="12700" cap="flat" cmpd="sng" algn="ctr">
+                      <a:solidFill>
+                        <a:srgbClr val="D5DEEA"/>
+                      </a:solidFill>
+                      <a:prstDash val="solid"/>
+                      <a:round/>
+                      <a:headEnd type="none" w="med" len="med"/>
+                      <a:tailEnd type="none" w="med" len="med"/>
+                    </a:lnT>
+                    <a:lnB w="12700" cap="flat" cmpd="sng" algn="ctr">
+                      <a:solidFill>
+                        <a:srgbClr val="D5DEEA"/>
+                      </a:solidFill>
+                      <a:prstDash val="solid"/>
+                      <a:round/>
+                      <a:headEnd type="none" w="med" len="med"/>
+                      <a:tailEnd type="none" w="med" len="med"/>
+                    </a:lnB>
+                    <a:solidFill>
+                      <a:srgbClr val="FFFFFF"/>
+                    </a:solidFill>
+                  </a:tcPr>
+                </a:tc>
+              </a:tr>
+              <a:tr h="402336">
                 <a:tc>
                   <a:txBody>
                     <a:bodyPr/>

</xml_diff>

<commit_message>
Enhance presentation content with updated data sources and improved example clarity
</commit_message>
<xml_diff>
--- a/presentation/Multilingual_Toxic_Classification.pptx
+++ b/presentation/Multilingual_Toxic_Classification.pptx
@@ -9418,8 +9418,8 @@
         </p:nvSpPr>
         <p:spPr>
           <a:xfrm>
-            <a:off x="1325880" y="2788920"/>
-            <a:ext cx="3456432" cy="365760"/>
+            <a:off x="1325880" y="2715768"/>
+            <a:ext cx="3456432" cy="256032"/>
           </a:xfrm>
           <a:prstGeom prst="rect">
             <a:avLst/>
@@ -9435,7 +9435,7 @@
               <a:buNone/>
             </a:pPr>
             <a:r>
-              <a:rPr lang="en-US" sz="1400" dirty="0">
+              <a:rPr lang="en-US" sz="1100" b="1" spc="100" kern="0" dirty="0">
                 <a:solidFill>
                   <a:srgbClr val="6B7480"/>
                 </a:solidFill>
@@ -9443,22 +9443,61 @@
                 <a:ea typeface="Calibri" pitchFamily="34" charset="-122"/>
                 <a:cs typeface="Calibri" pitchFamily="34" charset="-120"/>
               </a:rPr>
+              <a:t>≈ 3.0K eval comments</a:t>
+            </a:r>
+            <a:endParaRPr lang="en-US" sz="1100" dirty="0"/>
+          </a:p>
+        </p:txBody>
+      </p:sp>
+      <p:sp>
+        <p:nvSpPr>
+          <p:cNvPr id="14" name="Text 12"/>
+          <p:cNvSpPr/>
+          <p:nvPr/>
+        </p:nvSpPr>
+        <p:spPr>
+          <a:xfrm>
+            <a:off x="1325880" y="2999232"/>
+            <a:ext cx="3456432" cy="320040"/>
+          </a:xfrm>
+          <a:prstGeom prst="rect">
+            <a:avLst/>
+          </a:prstGeom>
+          <a:noFill/>
+          <a:ln/>
+        </p:spPr>
+        <p:txBody>
+          <a:bodyPr wrap="square" rtlCol="0" anchor="ctr"/>
+          <a:lstStyle/>
+          <a:p>
+            <a:pPr algn="ctr" indent="0" marL="0">
+              <a:buNone/>
+            </a:pPr>
+            <a:r>
+              <a:rPr lang="en-US" sz="1350" dirty="0">
+                <a:solidFill>
+                  <a:srgbClr val="6B7480"/>
+                </a:solidFill>
+                <a:latin typeface="Calibri" pitchFamily="34" charset="0"/>
+                <a:ea typeface="Calibri" pitchFamily="34" charset="-122"/>
+                <a:cs typeface="Calibri" pitchFamily="34" charset="-120"/>
+              </a:rPr>
               <a:t>0.65 → 0.89</a:t>
             </a:r>
-            <a:endParaRPr lang="en-US" sz="1400" dirty="0"/>
-          </a:p>
-        </p:txBody>
-      </p:sp>
-      <p:sp>
-        <p:nvSpPr>
-          <p:cNvPr id="14" name="Text 12"/>
-          <p:cNvSpPr/>
-          <p:nvPr/>
-        </p:nvSpPr>
-        <p:spPr>
-          <a:xfrm>
-            <a:off x="1325880" y="3108960"/>
-            <a:ext cx="3456432" cy="548640"/>
+            <a:endParaRPr lang="en-US" sz="1350" dirty="0"/>
+          </a:p>
+        </p:txBody>
+      </p:sp>
+      <p:sp>
+        <p:nvSpPr>
+          <p:cNvPr id="15" name="Text 13"/>
+          <p:cNvSpPr/>
+          <p:nvPr/>
+        </p:nvSpPr>
+        <p:spPr>
+          <a:xfrm>
+            <a:off x="1325880" y="3291840"/>
+            <a:ext cx="3456432" cy="502920"/>
           </a:xfrm>
           <a:prstGeom prst="rect">
             <a:avLst/>
@@ -9474,7 +9513,7 @@
               <a:buNone/>
             </a:pPr>
             <a:r>
-              <a:rPr lang="en-US" sz="3400" b="1" dirty="0">
+              <a:rPr lang="en-US" sz="3200" b="1" dirty="0">
                 <a:solidFill>
                   <a:srgbClr val="00A896"/>
                 </a:solidFill>
@@ -9484,20 +9523,20 @@
               </a:rPr>
               <a:t>+0.24</a:t>
             </a:r>
-            <a:endParaRPr lang="en-US" sz="3400" dirty="0"/>
-          </a:p>
-        </p:txBody>
-      </p:sp>
-      <p:sp>
-        <p:nvSpPr>
-          <p:cNvPr id="15" name="Text 13"/>
-          <p:cNvSpPr/>
-          <p:nvPr/>
-        </p:nvSpPr>
-        <p:spPr>
-          <a:xfrm>
-            <a:off x="1325880" y="3675888"/>
-            <a:ext cx="3456432" cy="274320"/>
+            <a:endParaRPr lang="en-US" sz="3200" dirty="0"/>
+          </a:p>
+        </p:txBody>
+      </p:sp>
+      <p:sp>
+        <p:nvSpPr>
+          <p:cNvPr id="16" name="Text 14"/>
+          <p:cNvSpPr/>
+          <p:nvPr/>
+        </p:nvSpPr>
+        <p:spPr>
+          <a:xfrm>
+            <a:off x="1325880" y="3803904"/>
+            <a:ext cx="3456432" cy="256032"/>
           </a:xfrm>
           <a:prstGeom prst="rect">
             <a:avLst/>
@@ -9529,14 +9568,14 @@
       </p:sp>
       <p:sp>
         <p:nvSpPr>
-          <p:cNvPr id="16" name="Text 14"/>
-          <p:cNvSpPr/>
-          <p:nvPr/>
-        </p:nvSpPr>
-        <p:spPr>
-          <a:xfrm>
-            <a:off x="1581912" y="4023360"/>
-            <a:ext cx="2944368" cy="1417320"/>
+          <p:cNvPr id="17" name="Text 15"/>
+          <p:cNvSpPr/>
+          <p:nvPr/>
+        </p:nvSpPr>
+        <p:spPr>
+          <a:xfrm>
+            <a:off x="1581912" y="4114800"/>
+            <a:ext cx="2944368" cy="1371600"/>
           </a:xfrm>
           <a:prstGeom prst="rect">
             <a:avLst/>
@@ -9552,7 +9591,7 @@
               <a:buNone/>
             </a:pPr>
             <a:r>
-              <a:rPr lang="en-US" sz="1250" dirty="0">
+              <a:rPr lang="en-US" sz="1200" dirty="0">
                 <a:solidFill>
                   <a:srgbClr val="243044"/>
                 </a:solidFill>
@@ -9562,13 +9601,13 @@
               </a:rPr>
               <a:t>Biggest jump. Not because Turkish is close to English — it isn't. mBERT simply saw a lot of Turkish while pretraining, and the classical baseline started very low, so there was the most room to gain.</a:t>
             </a:r>
-            <a:endParaRPr lang="en-US" sz="1250" dirty="0"/>
-          </a:p>
-        </p:txBody>
-      </p:sp>
-      <p:sp>
-        <p:nvSpPr>
-          <p:cNvPr id="17" name="Shape 15"/>
+            <a:endParaRPr lang="en-US" sz="1200" dirty="0"/>
+          </a:p>
+        </p:txBody>
+      </p:sp>
+      <p:sp>
+        <p:nvSpPr>
+          <p:cNvPr id="18" name="Shape 16"/>
           <p:cNvSpPr/>
           <p:nvPr/>
         </p:nvSpPr>
@@ -9595,7 +9634,7 @@
       </p:sp>
       <p:sp>
         <p:nvSpPr>
-          <p:cNvPr id="18" name="Shape 16"/>
+          <p:cNvPr id="19" name="Shape 17"/>
           <p:cNvSpPr/>
           <p:nvPr/>
         </p:nvSpPr>
@@ -9615,7 +9654,7 @@
       </p:sp>
       <p:sp>
         <p:nvSpPr>
-          <p:cNvPr id="19" name="Text 17"/>
+          <p:cNvPr id="20" name="Text 18"/>
           <p:cNvSpPr/>
           <p:nvPr/>
         </p:nvSpPr>
@@ -9654,14 +9693,14 @@
       </p:sp>
       <p:sp>
         <p:nvSpPr>
-          <p:cNvPr id="20" name="Text 18"/>
-          <p:cNvSpPr/>
-          <p:nvPr/>
-        </p:nvSpPr>
-        <p:spPr>
-          <a:xfrm>
-            <a:off x="4946904" y="2788920"/>
-            <a:ext cx="3456432" cy="365760"/>
+          <p:cNvPr id="21" name="Text 19"/>
+          <p:cNvSpPr/>
+          <p:nvPr/>
+        </p:nvSpPr>
+        <p:spPr>
+          <a:xfrm>
+            <a:off x="4946904" y="2715768"/>
+            <a:ext cx="3456432" cy="256032"/>
           </a:xfrm>
           <a:prstGeom prst="rect">
             <a:avLst/>
@@ -9677,7 +9716,7 @@
               <a:buNone/>
             </a:pPr>
             <a:r>
-              <a:rPr lang="en-US" sz="1400" dirty="0">
+              <a:rPr lang="en-US" sz="1100" b="1" spc="100" kern="0" dirty="0">
                 <a:solidFill>
                   <a:srgbClr val="6B7480"/>
                 </a:solidFill>
@@ -9685,22 +9724,61 @@
                 <a:ea typeface="Calibri" pitchFamily="34" charset="-122"/>
                 <a:cs typeface="Calibri" pitchFamily="34" charset="-120"/>
               </a:rPr>
+              <a:t>≈ 2.5K eval comments</a:t>
+            </a:r>
+            <a:endParaRPr lang="en-US" sz="1100" dirty="0"/>
+          </a:p>
+        </p:txBody>
+      </p:sp>
+      <p:sp>
+        <p:nvSpPr>
+          <p:cNvPr id="22" name="Text 20"/>
+          <p:cNvSpPr/>
+          <p:nvPr/>
+        </p:nvSpPr>
+        <p:spPr>
+          <a:xfrm>
+            <a:off x="4946904" y="2999232"/>
+            <a:ext cx="3456432" cy="320040"/>
+          </a:xfrm>
+          <a:prstGeom prst="rect">
+            <a:avLst/>
+          </a:prstGeom>
+          <a:noFill/>
+          <a:ln/>
+        </p:spPr>
+        <p:txBody>
+          <a:bodyPr wrap="square" rtlCol="0" anchor="ctr"/>
+          <a:lstStyle/>
+          <a:p>
+            <a:pPr algn="ctr" indent="0" marL="0">
+              <a:buNone/>
+            </a:pPr>
+            <a:r>
+              <a:rPr lang="en-US" sz="1350" dirty="0">
+                <a:solidFill>
+                  <a:srgbClr val="6B7480"/>
+                </a:solidFill>
+                <a:latin typeface="Calibri" pitchFamily="34" charset="0"/>
+                <a:ea typeface="Calibri" pitchFamily="34" charset="-122"/>
+                <a:cs typeface="Calibri" pitchFamily="34" charset="-120"/>
+              </a:rPr>
               <a:t>0.61 → 0.82</a:t>
             </a:r>
-            <a:endParaRPr lang="en-US" sz="1400" dirty="0"/>
-          </a:p>
-        </p:txBody>
-      </p:sp>
-      <p:sp>
-        <p:nvSpPr>
-          <p:cNvPr id="21" name="Text 19"/>
-          <p:cNvSpPr/>
-          <p:nvPr/>
-        </p:nvSpPr>
-        <p:spPr>
-          <a:xfrm>
-            <a:off x="4946904" y="3108960"/>
-            <a:ext cx="3456432" cy="548640"/>
+            <a:endParaRPr lang="en-US" sz="1350" dirty="0"/>
+          </a:p>
+        </p:txBody>
+      </p:sp>
+      <p:sp>
+        <p:nvSpPr>
+          <p:cNvPr id="23" name="Text 21"/>
+          <p:cNvSpPr/>
+          <p:nvPr/>
+        </p:nvSpPr>
+        <p:spPr>
+          <a:xfrm>
+            <a:off x="4946904" y="3291840"/>
+            <a:ext cx="3456432" cy="502920"/>
           </a:xfrm>
           <a:prstGeom prst="rect">
             <a:avLst/>
@@ -9716,7 +9794,7 @@
               <a:buNone/>
             </a:pPr>
             <a:r>
-              <a:rPr lang="en-US" sz="3400" b="1" dirty="0">
+              <a:rPr lang="en-US" sz="3200" b="1" dirty="0">
                 <a:solidFill>
                   <a:srgbClr val="028090"/>
                 </a:solidFill>
@@ -9726,20 +9804,20 @@
               </a:rPr>
               <a:t>+0.21</a:t>
             </a:r>
-            <a:endParaRPr lang="en-US" sz="3400" dirty="0"/>
-          </a:p>
-        </p:txBody>
-      </p:sp>
-      <p:sp>
-        <p:nvSpPr>
-          <p:cNvPr id="22" name="Text 20"/>
-          <p:cNvSpPr/>
-          <p:nvPr/>
-        </p:nvSpPr>
-        <p:spPr>
-          <a:xfrm>
-            <a:off x="4946904" y="3675888"/>
-            <a:ext cx="3456432" cy="274320"/>
+            <a:endParaRPr lang="en-US" sz="3200" dirty="0"/>
+          </a:p>
+        </p:txBody>
+      </p:sp>
+      <p:sp>
+        <p:nvSpPr>
+          <p:cNvPr id="24" name="Text 22"/>
+          <p:cNvSpPr/>
+          <p:nvPr/>
+        </p:nvSpPr>
+        <p:spPr>
+          <a:xfrm>
+            <a:off x="4946904" y="3803904"/>
+            <a:ext cx="3456432" cy="256032"/>
           </a:xfrm>
           <a:prstGeom prst="rect">
             <a:avLst/>
@@ -9771,14 +9849,14 @@
       </p:sp>
       <p:sp>
         <p:nvSpPr>
-          <p:cNvPr id="23" name="Text 21"/>
-          <p:cNvSpPr/>
-          <p:nvPr/>
-        </p:nvSpPr>
-        <p:spPr>
-          <a:xfrm>
-            <a:off x="5202936" y="4023360"/>
-            <a:ext cx="2944368" cy="1417320"/>
+          <p:cNvPr id="25" name="Text 23"/>
+          <p:cNvSpPr/>
+          <p:nvPr/>
+        </p:nvSpPr>
+        <p:spPr>
+          <a:xfrm>
+            <a:off x="5202936" y="4114800"/>
+            <a:ext cx="2944368" cy="1371600"/>
           </a:xfrm>
           <a:prstGeom prst="rect">
             <a:avLst/>
@@ -9794,7 +9872,7 @@
               <a:buNone/>
             </a:pPr>
             <a:r>
-              <a:rPr lang="en-US" sz="1250" dirty="0">
+              <a:rPr lang="en-US" sz="1200" dirty="0">
                 <a:solidFill>
                   <a:srgbClr val="243044"/>
                 </a:solidFill>
@@ -9804,13 +9882,13 @@
               </a:rPr>
               <a:t>Solid gain. Shares the Latin script and many roots with English, so toxic cues line up fairly well in mBERT's shared space.</a:t>
             </a:r>
-            <a:endParaRPr lang="en-US" sz="1250" dirty="0"/>
-          </a:p>
-        </p:txBody>
-      </p:sp>
-      <p:sp>
-        <p:nvSpPr>
-          <p:cNvPr id="24" name="Shape 22"/>
+            <a:endParaRPr lang="en-US" sz="1200" dirty="0"/>
+          </a:p>
+        </p:txBody>
+      </p:sp>
+      <p:sp>
+        <p:nvSpPr>
+          <p:cNvPr id="26" name="Shape 24"/>
           <p:cNvSpPr/>
           <p:nvPr/>
         </p:nvSpPr>
@@ -9837,7 +9915,7 @@
       </p:sp>
       <p:sp>
         <p:nvSpPr>
-          <p:cNvPr id="25" name="Shape 23"/>
+          <p:cNvPr id="27" name="Shape 25"/>
           <p:cNvSpPr/>
           <p:nvPr/>
         </p:nvSpPr>
@@ -9857,7 +9935,7 @@
       </p:sp>
       <p:sp>
         <p:nvSpPr>
-          <p:cNvPr id="26" name="Text 24"/>
+          <p:cNvPr id="28" name="Text 26"/>
           <p:cNvSpPr/>
           <p:nvPr/>
         </p:nvSpPr>
@@ -9896,14 +9974,14 @@
       </p:sp>
       <p:sp>
         <p:nvSpPr>
-          <p:cNvPr id="27" name="Text 25"/>
-          <p:cNvSpPr/>
-          <p:nvPr/>
-        </p:nvSpPr>
-        <p:spPr>
-          <a:xfrm>
-            <a:off x="8567928" y="2788920"/>
-            <a:ext cx="3456432" cy="365760"/>
+          <p:cNvPr id="29" name="Text 27"/>
+          <p:cNvSpPr/>
+          <p:nvPr/>
+        </p:nvSpPr>
+        <p:spPr>
+          <a:xfrm>
+            <a:off x="8567928" y="2715768"/>
+            <a:ext cx="3456432" cy="256032"/>
           </a:xfrm>
           <a:prstGeom prst="rect">
             <a:avLst/>
@@ -9919,7 +9997,7 @@
               <a:buNone/>
             </a:pPr>
             <a:r>
-              <a:rPr lang="en-US" sz="1400" dirty="0">
+              <a:rPr lang="en-US" sz="1100" b="1" spc="100" kern="0" dirty="0">
                 <a:solidFill>
                   <a:srgbClr val="6B7480"/>
                 </a:solidFill>
@@ -9927,22 +10005,61 @@
                 <a:ea typeface="Calibri" pitchFamily="34" charset="-122"/>
                 <a:cs typeface="Calibri" pitchFamily="34" charset="-120"/>
               </a:rPr>
+              <a:t>≈ 2.5K eval comments</a:t>
+            </a:r>
+            <a:endParaRPr lang="en-US" sz="1100" dirty="0"/>
+          </a:p>
+        </p:txBody>
+      </p:sp>
+      <p:sp>
+        <p:nvSpPr>
+          <p:cNvPr id="30" name="Text 28"/>
+          <p:cNvSpPr/>
+          <p:nvPr/>
+        </p:nvSpPr>
+        <p:spPr>
+          <a:xfrm>
+            <a:off x="8567928" y="2999232"/>
+            <a:ext cx="3456432" cy="320040"/>
+          </a:xfrm>
+          <a:prstGeom prst="rect">
+            <a:avLst/>
+          </a:prstGeom>
+          <a:noFill/>
+          <a:ln/>
+        </p:spPr>
+        <p:txBody>
+          <a:bodyPr wrap="square" rtlCol="0" anchor="ctr"/>
+          <a:lstStyle/>
+          <a:p>
+            <a:pPr algn="ctr" indent="0" marL="0">
+              <a:buNone/>
+            </a:pPr>
+            <a:r>
+              <a:rPr lang="en-US" sz="1350" dirty="0">
+                <a:solidFill>
+                  <a:srgbClr val="6B7480"/>
+                </a:solidFill>
+                <a:latin typeface="Calibri" pitchFamily="34" charset="0"/>
+                <a:ea typeface="Calibri" pitchFamily="34" charset="-122"/>
+                <a:cs typeface="Calibri" pitchFamily="34" charset="-120"/>
+              </a:rPr>
               <a:t>0.60 → 0.77</a:t>
             </a:r>
-            <a:endParaRPr lang="en-US" sz="1400" dirty="0"/>
-          </a:p>
-        </p:txBody>
-      </p:sp>
-      <p:sp>
-        <p:nvSpPr>
-          <p:cNvPr id="28" name="Text 26"/>
-          <p:cNvSpPr/>
-          <p:nvPr/>
-        </p:nvSpPr>
-        <p:spPr>
-          <a:xfrm>
-            <a:off x="8567928" y="3108960"/>
-            <a:ext cx="3456432" cy="548640"/>
+            <a:endParaRPr lang="en-US" sz="1350" dirty="0"/>
+          </a:p>
+        </p:txBody>
+      </p:sp>
+      <p:sp>
+        <p:nvSpPr>
+          <p:cNvPr id="31" name="Text 29"/>
+          <p:cNvSpPr/>
+          <p:nvPr/>
+        </p:nvSpPr>
+        <p:spPr>
+          <a:xfrm>
+            <a:off x="8567928" y="3291840"/>
+            <a:ext cx="3456432" cy="502920"/>
           </a:xfrm>
           <a:prstGeom prst="rect">
             <a:avLst/>
@@ -9958,7 +10075,7 @@
               <a:buNone/>
             </a:pPr>
             <a:r>
-              <a:rPr lang="en-US" sz="3400" b="1" dirty="0">
+              <a:rPr lang="en-US" sz="3200" b="1" dirty="0">
                 <a:solidFill>
                   <a:srgbClr val="1E2761"/>
                 </a:solidFill>
@@ -9968,20 +10085,20 @@
               </a:rPr>
               <a:t>+0.17</a:t>
             </a:r>
-            <a:endParaRPr lang="en-US" sz="3400" dirty="0"/>
-          </a:p>
-        </p:txBody>
-      </p:sp>
-      <p:sp>
-        <p:nvSpPr>
-          <p:cNvPr id="29" name="Text 27"/>
-          <p:cNvSpPr/>
-          <p:nvPr/>
-        </p:nvSpPr>
-        <p:spPr>
-          <a:xfrm>
-            <a:off x="8567928" y="3675888"/>
-            <a:ext cx="3456432" cy="274320"/>
+            <a:endParaRPr lang="en-US" sz="3200" dirty="0"/>
+          </a:p>
+        </p:txBody>
+      </p:sp>
+      <p:sp>
+        <p:nvSpPr>
+          <p:cNvPr id="32" name="Text 30"/>
+          <p:cNvSpPr/>
+          <p:nvPr/>
+        </p:nvSpPr>
+        <p:spPr>
+          <a:xfrm>
+            <a:off x="8567928" y="3803904"/>
+            <a:ext cx="3456432" cy="256032"/>
           </a:xfrm>
           <a:prstGeom prst="rect">
             <a:avLst/>
@@ -10013,14 +10130,14 @@
       </p:sp>
       <p:sp>
         <p:nvSpPr>
-          <p:cNvPr id="30" name="Text 28"/>
-          <p:cNvSpPr/>
-          <p:nvPr/>
-        </p:nvSpPr>
-        <p:spPr>
-          <a:xfrm>
-            <a:off x="8823960" y="4023360"/>
-            <a:ext cx="2944368" cy="1417320"/>
+          <p:cNvPr id="33" name="Text 31"/>
+          <p:cNvSpPr/>
+          <p:nvPr/>
+        </p:nvSpPr>
+        <p:spPr>
+          <a:xfrm>
+            <a:off x="8823960" y="4114800"/>
+            <a:ext cx="2944368" cy="1371600"/>
           </a:xfrm>
           <a:prstGeom prst="rect">
             <a:avLst/>
@@ -10036,7 +10153,7 @@
               <a:buNone/>
             </a:pPr>
             <a:r>
-              <a:rPr lang="en-US" sz="1250" dirty="0">
+              <a:rPr lang="en-US" sz="1200" dirty="0">
                 <a:solidFill>
                   <a:srgbClr val="243044"/>
                 </a:solidFill>
@@ -10046,13 +10163,13 @@
               </a:rPr>
               <a:t>Smallest gain / hardest. Likely fewer toxic words overlap with what was seen in English training, so subtler insults slip through. (Partly our interpretation.)</a:t>
             </a:r>
-            <a:endParaRPr lang="en-US" sz="1250" dirty="0"/>
-          </a:p>
-        </p:txBody>
-      </p:sp>
-      <p:sp>
-        <p:nvSpPr>
-          <p:cNvPr id="31" name="Text 29"/>
+            <a:endParaRPr lang="en-US" sz="1200" dirty="0"/>
+          </a:p>
+        </p:txBody>
+      </p:sp>
+      <p:sp>
+        <p:nvSpPr>
+          <p:cNvPr id="34" name="Text 32"/>
           <p:cNvSpPr/>
           <p:nvPr/>
         </p:nvSpPr>
@@ -18690,8 +18807,8 @@
         </p:nvSpPr>
         <p:spPr>
           <a:xfrm>
-            <a:off x="1325880" y="1554480"/>
-            <a:ext cx="5074920" cy="2651760"/>
+            <a:off x="1325880" y="1508760"/>
+            <a:ext cx="5029200" cy="2194560"/>
           </a:xfrm>
           <a:prstGeom prst="rect">
             <a:avLst/>
@@ -18711,14 +18828,14 @@
               <a:buChar char="•"/>
             </a:pPr>
             <a:r>
-              <a:rPr lang="en-US" sz="1400" dirty="0">
+              <a:rPr lang="en-US" sz="1350" dirty="0">
                 <a:solidFill>
                   <a:srgbClr val="243044"/>
                 </a:solidFill>
               </a:rPr>
               <a:t>Source: Jigsaw Multilingual Toxic Comment Classification (Kaggle).</a:t>
             </a:r>
-            <a:endParaRPr lang="en-US" sz="1400" dirty="0"/>
+            <a:endParaRPr lang="en-US" sz="1350" dirty="0"/>
           </a:p>
           <a:p>
             <a:pPr marL="203200" indent="-203200">
@@ -18729,14 +18846,14 @@
               <a:buChar char="•"/>
             </a:pPr>
             <a:r>
-              <a:rPr lang="en-US" sz="1400" dirty="0">
+              <a:rPr lang="en-US" sz="1350" dirty="0">
                 <a:solidFill>
                   <a:srgbClr val="243044"/>
                 </a:solidFill>
               </a:rPr>
               <a:t>Train: ~223K English comments, binary label.</a:t>
             </a:r>
-            <a:endParaRPr lang="en-US" sz="1400" dirty="0"/>
+            <a:endParaRPr lang="en-US" sz="1350" dirty="0"/>
           </a:p>
           <a:p>
             <a:pPr marL="203200" indent="-203200">
@@ -18747,14 +18864,14 @@
               <a:buChar char="•"/>
             </a:pPr>
             <a:r>
-              <a:rPr lang="en-US" sz="1400" dirty="0">
+              <a:rPr lang="en-US" sz="1350" dirty="0">
                 <a:solidFill>
                   <a:srgbClr val="243044"/>
                 </a:solidFill>
               </a:rPr>
               <a:t>Validation: ~8K labelled multilingual (tr 3.0K · es 2.5K · it 2.5K).</a:t>
             </a:r>
-            <a:endParaRPr lang="en-US" sz="1400" dirty="0"/>
+            <a:endParaRPr lang="en-US" sz="1350" dirty="0"/>
           </a:p>
           <a:p>
             <a:pPr marL="203200" indent="-203200">
@@ -18765,14 +18882,14 @@
               <a:buChar char="•"/>
             </a:pPr>
             <a:r>
-              <a:rPr lang="en-US" sz="1400" dirty="0">
+              <a:rPr lang="en-US" sz="1350" dirty="0">
                 <a:solidFill>
                   <a:srgbClr val="243044"/>
                 </a:solidFill>
               </a:rPr>
-              <a:t>Test: ~63K multilingual but unlabelled — so labelled cross-lingual evaluation uses the validation split.</a:t>
-            </a:r>
-            <a:endParaRPr lang="en-US" sz="1400" dirty="0"/>
+              <a:t>Test: ~63K multilingual but unlabelled — labelled cross-lingual evaluation uses the validation split.</a:t>
+            </a:r>
+            <a:endParaRPr lang="en-US" sz="1350" dirty="0"/>
           </a:p>
         </p:txBody>
       </p:sp>
@@ -18784,12 +18901,12 @@
         </p:nvSpPr>
         <p:spPr>
           <a:xfrm>
-            <a:off x="6629400" y="1554480"/>
-            <a:ext cx="4983480" cy="1078992"/>
+            <a:off x="1325880" y="3840480"/>
+            <a:ext cx="5029200" cy="2331720"/>
           </a:xfrm>
           <a:prstGeom prst="roundRect">
             <a:avLst>
-              <a:gd name="adj" fmla="val 5085"/>
+              <a:gd name="adj" fmla="val 3137"/>
             </a:avLst>
           </a:prstGeom>
           <a:solidFill>
@@ -18801,6 +18918,13 @@
             </a:solidFill>
             <a:prstDash val="solid"/>
           </a:ln>
+          <a:effectLst>
+            <a:outerShdw sx="100000" sy="100000" kx="0" ky="0" algn="bl" rotWithShape="0" blurRad="76200" dist="25400" dir="5400000">
+              <a:srgbClr val="AAB4C2">
+                <a:alpha val="35000"/>
+              </a:srgbClr>
+            </a:outerShdw>
+          </a:effectLst>
         </p:spPr>
       </p:sp>
       <p:sp>
@@ -18811,14 +18935,14 @@
         </p:nvSpPr>
         <p:spPr>
           <a:xfrm>
-            <a:off x="6629400" y="1554480"/>
-            <a:ext cx="91440" cy="1078992"/>
+            <a:off x="1325880" y="3840480"/>
+            <a:ext cx="5029200" cy="438912"/>
           </a:xfrm>
           <a:prstGeom prst="rect">
             <a:avLst/>
           </a:prstGeom>
           <a:solidFill>
-            <a:srgbClr val="1E8449"/>
+            <a:srgbClr val="1E2761"/>
           </a:solidFill>
           <a:ln/>
         </p:spPr>
@@ -18831,8 +18955,8 @@
         </p:nvSpPr>
         <p:spPr>
           <a:xfrm>
-            <a:off x="6858000" y="1645920"/>
-            <a:ext cx="4617720" cy="274320"/>
+            <a:off x="1508760" y="3840480"/>
+            <a:ext cx="4754880" cy="438912"/>
           </a:xfrm>
           <a:prstGeom prst="rect">
             <a:avLst/>
@@ -18848,17 +18972,17 @@
               <a:buNone/>
             </a:pPr>
             <a:r>
-              <a:rPr lang="en-US" sz="1100" b="1" spc="100" kern="0" dirty="0">
-                <a:solidFill>
-                  <a:srgbClr val="1E8449"/>
-                </a:solidFill>
-                <a:latin typeface="Calibri" pitchFamily="34" charset="0"/>
-                <a:ea typeface="Calibri" pitchFamily="34" charset="-122"/>
-                <a:cs typeface="Calibri" pitchFamily="34" charset="-120"/>
-              </a:rPr>
-              <a:t>NON-TOXIC · en</a:t>
-            </a:r>
-            <a:endParaRPr lang="en-US" sz="1100" dirty="0"/>
+              <a:rPr lang="en-US" sz="1400" b="1" dirty="0">
+                <a:solidFill>
+                  <a:srgbClr val="FFFFFF"/>
+                </a:solidFill>
+                <a:latin typeface="Georgia" pitchFamily="34" charset="0"/>
+                <a:ea typeface="Georgia" pitchFamily="34" charset="-122"/>
+                <a:cs typeface="Georgia" pitchFamily="34" charset="-120"/>
+              </a:rPr>
+              <a:t>Where the data comes from</a:t>
+            </a:r>
+            <a:endParaRPr lang="en-US" sz="1400" dirty="0"/>
           </a:p>
         </p:txBody>
       </p:sp>
@@ -18870,34 +18994,89 @@
         </p:nvSpPr>
         <p:spPr>
           <a:xfrm>
-            <a:off x="6858000" y="1901952"/>
-            <a:ext cx="4572000" cy="685800"/>
-          </a:xfrm>
-          <a:prstGeom prst="rect">
-            <a:avLst/>
-          </a:prstGeom>
-          <a:noFill/>
-          <a:ln/>
-        </p:spPr>
-        <p:txBody>
-          <a:bodyPr wrap="square" rtlCol="0" anchor="ctr"/>
-          <a:lstStyle/>
-          <a:p>
-            <a:pPr indent="0" marL="0">
-              <a:buNone/>
-            </a:pPr>
-            <a:r>
-              <a:rPr lang="en-US" sz="1250" i="1" dirty="0">
+            <a:off x="1554480" y="4370832"/>
+            <a:ext cx="4617720" cy="1737360"/>
+          </a:xfrm>
+          <a:prstGeom prst="rect">
+            <a:avLst/>
+          </a:prstGeom>
+          <a:noFill/>
+          <a:ln/>
+        </p:spPr>
+        <p:txBody>
+          <a:bodyPr wrap="square" rtlCol="0" anchor="ctr"/>
+          <a:lstStyle/>
+          <a:p>
+            <a:pPr marL="203200" indent="-203200">
+              <a:spcAft>
+                <a:spcPts val="800"/>
+              </a:spcAft>
+              <a:buSzPct val="100000"/>
+              <a:buChar char="•"/>
+            </a:pPr>
+            <a:r>
+              <a:rPr lang="en-US" sz="1150" dirty="0">
                 <a:solidFill>
                   <a:srgbClr val="243044"/>
                 </a:solidFill>
-                <a:latin typeface="Calibri" pitchFamily="34" charset="0"/>
-                <a:ea typeface="Calibri" pitchFamily="34" charset="-122"/>
-                <a:cs typeface="Calibri" pitchFamily="34" charset="-120"/>
-              </a:rPr>
-              <a:t>“You, sir, are my hero. Any chance you remember what page that’s on?”</a:t>
-            </a:r>
-            <a:endParaRPr lang="en-US" sz="1250" dirty="0"/>
+              </a:rPr>
+              <a:t>Released by Jigsaw (Google’s Conversation AI team) on Kaggle, 2020.</a:t>
+            </a:r>
+            <a:endParaRPr lang="en-US" sz="1150" dirty="0"/>
+          </a:p>
+          <a:p>
+            <a:pPr marL="203200" indent="-203200">
+              <a:spcAft>
+                <a:spcPts val="800"/>
+              </a:spcAft>
+              <a:buSzPct val="100000"/>
+              <a:buChar char="•"/>
+            </a:pPr>
+            <a:r>
+              <a:rPr lang="en-US" sz="1150" dirty="0">
+                <a:solidFill>
+                  <a:srgbClr val="243044"/>
+                </a:solidFill>
+              </a:rPr>
+              <a:t>English comments: real Wikipedia talk-page edits + Civil Comments, reused from earlier Jigsaw challenges.</a:t>
+            </a:r>
+            <a:endParaRPr lang="en-US" sz="1150" dirty="0"/>
+          </a:p>
+          <a:p>
+            <a:pPr marL="203200" indent="-203200">
+              <a:spcAft>
+                <a:spcPts val="800"/>
+              </a:spcAft>
+              <a:buSzPct val="100000"/>
+              <a:buChar char="•"/>
+            </a:pPr>
+            <a:r>
+              <a:rPr lang="en-US" sz="1150" dirty="0">
+                <a:solidFill>
+                  <a:srgbClr val="243044"/>
+                </a:solidFill>
+              </a:rPr>
+              <a:t>Multilingual val / test: non-English Wikipedia talk-page comments, newly gathered for this competition.</a:t>
+            </a:r>
+            <a:endParaRPr lang="en-US" sz="1150" dirty="0"/>
+          </a:p>
+          <a:p>
+            <a:pPr marL="203200" indent="-203200">
+              <a:spcAft>
+                <a:spcPts val="800"/>
+              </a:spcAft>
+              <a:buSzPct val="100000"/>
+              <a:buChar char="•"/>
+            </a:pPr>
+            <a:r>
+              <a:rPr lang="en-US" sz="1150" dirty="0">
+                <a:solidFill>
+                  <a:srgbClr val="243044"/>
+                </a:solidFill>
+              </a:rPr>
+              <a:t>Toxicity labels assigned by human annotators.</a:t>
+            </a:r>
+            <a:endParaRPr lang="en-US" sz="1150" dirty="0"/>
           </a:p>
         </p:txBody>
       </p:sp>
@@ -18909,12 +19088,12 @@
         </p:nvSpPr>
         <p:spPr>
           <a:xfrm>
-            <a:off x="6629400" y="2743200"/>
-            <a:ext cx="4983480" cy="1078992"/>
+            <a:off x="6629400" y="1417320"/>
+            <a:ext cx="4983480" cy="713232"/>
           </a:xfrm>
           <a:prstGeom prst="roundRect">
             <a:avLst>
-              <a:gd name="adj" fmla="val 5085"/>
+              <a:gd name="adj" fmla="val 7692"/>
             </a:avLst>
           </a:prstGeom>
           <a:solidFill>
@@ -18936,14 +19115,14 @@
         </p:nvSpPr>
         <p:spPr>
           <a:xfrm>
-            <a:off x="6629400" y="2743200"/>
-            <a:ext cx="91440" cy="1078992"/>
+            <a:off x="6629400" y="1417320"/>
+            <a:ext cx="91440" cy="713232"/>
           </a:xfrm>
           <a:prstGeom prst="rect">
             <a:avLst/>
           </a:prstGeom>
           <a:solidFill>
-            <a:srgbClr val="C0392B"/>
+            <a:srgbClr val="1E8449"/>
           </a:solidFill>
           <a:ln/>
         </p:spPr>
@@ -18956,8 +19135,8 @@
         </p:nvSpPr>
         <p:spPr>
           <a:xfrm>
-            <a:off x="6858000" y="2834640"/>
-            <a:ext cx="4617720" cy="274320"/>
+            <a:off x="6858000" y="1481328"/>
+            <a:ext cx="4617720" cy="219456"/>
           </a:xfrm>
           <a:prstGeom prst="rect">
             <a:avLst/>
@@ -18973,17 +19152,17 @@
               <a:buNone/>
             </a:pPr>
             <a:r>
-              <a:rPr lang="en-US" sz="1100" b="1" spc="100" kern="0" dirty="0">
-                <a:solidFill>
-                  <a:srgbClr val="C0392B"/>
+              <a:rPr lang="en-US" sz="1000" b="1" spc="100" kern="0" dirty="0">
+                <a:solidFill>
+                  <a:srgbClr val="1E8449"/>
                 </a:solidFill>
                 <a:latin typeface="Calibri" pitchFamily="34" charset="0"/>
                 <a:ea typeface="Calibri" pitchFamily="34" charset="-122"/>
                 <a:cs typeface="Calibri" pitchFamily="34" charset="-120"/>
               </a:rPr>
-              <a:t>TOXIC · en</a:t>
-            </a:r>
-            <a:endParaRPr lang="en-US" sz="1100" dirty="0"/>
+              <a:t>NON-TOXIC · en</a:t>
+            </a:r>
+            <a:endParaRPr lang="en-US" sz="1000" dirty="0"/>
           </a:p>
         </p:txBody>
       </p:sp>
@@ -18995,24 +19174,24 @@
         </p:nvSpPr>
         <p:spPr>
           <a:xfrm>
-            <a:off x="6858000" y="3090672"/>
-            <a:ext cx="4572000" cy="685800"/>
-          </a:xfrm>
-          <a:prstGeom prst="rect">
-            <a:avLst/>
-          </a:prstGeom>
-          <a:noFill/>
-          <a:ln/>
-        </p:spPr>
-        <p:txBody>
-          <a:bodyPr wrap="square" rtlCol="0" anchor="ctr"/>
+            <a:off x="6858000" y="1700784"/>
+            <a:ext cx="4572000" cy="402336"/>
+          </a:xfrm>
+          <a:prstGeom prst="rect">
+            <a:avLst/>
+          </a:prstGeom>
+          <a:noFill/>
+          <a:ln/>
+        </p:spPr>
+        <p:txBody>
+          <a:bodyPr wrap="square" rtlCol="0" anchor="t"/>
           <a:lstStyle/>
           <a:p>
             <a:pPr indent="0" marL="0">
               <a:buNone/>
             </a:pPr>
             <a:r>
-              <a:rPr lang="en-US" sz="1250" i="1" dirty="0">
+              <a:rPr lang="en-US" sz="1150" i="1" dirty="0">
                 <a:solidFill>
                   <a:srgbClr val="243044"/>
                 </a:solidFill>
@@ -19020,9 +19199,9 @@
                 <a:ea typeface="Calibri" pitchFamily="34" charset="-122"/>
                 <a:cs typeface="Calibri" pitchFamily="34" charset="-120"/>
               </a:rPr>
-              <a:t>“COCKS∗∗∗ER, before you piss around on my work…”</a:t>
-            </a:r>
-            <a:endParaRPr lang="en-US" sz="1250" dirty="0"/>
+              <a:t>“You, sir, are my hero. Any chance you remember what page that’s on?”</a:t>
+            </a:r>
+            <a:endParaRPr lang="en-US" sz="1150" dirty="0"/>
           </a:p>
         </p:txBody>
       </p:sp>
@@ -19034,12 +19213,12 @@
         </p:nvSpPr>
         <p:spPr>
           <a:xfrm>
-            <a:off x="6629400" y="3931920"/>
-            <a:ext cx="4983480" cy="1078992"/>
+            <a:off x="6629400" y="2240280"/>
+            <a:ext cx="4983480" cy="713232"/>
           </a:xfrm>
           <a:prstGeom prst="roundRect">
             <a:avLst>
-              <a:gd name="adj" fmla="val 5085"/>
+              <a:gd name="adj" fmla="val 7692"/>
             </a:avLst>
           </a:prstGeom>
           <a:solidFill>
@@ -19061,8 +19240,8 @@
         </p:nvSpPr>
         <p:spPr>
           <a:xfrm>
-            <a:off x="6629400" y="3931920"/>
-            <a:ext cx="91440" cy="1078992"/>
+            <a:off x="6629400" y="2240280"/>
+            <a:ext cx="91440" cy="713232"/>
           </a:xfrm>
           <a:prstGeom prst="rect">
             <a:avLst/>
@@ -19081,8 +19260,8 @@
         </p:nvSpPr>
         <p:spPr>
           <a:xfrm>
-            <a:off x="6858000" y="4023360"/>
-            <a:ext cx="4617720" cy="274320"/>
+            <a:off x="6858000" y="2304288"/>
+            <a:ext cx="4617720" cy="219456"/>
           </a:xfrm>
           <a:prstGeom prst="rect">
             <a:avLst/>
@@ -19098,7 +19277,7 @@
               <a:buNone/>
             </a:pPr>
             <a:r>
-              <a:rPr lang="en-US" sz="1100" b="1" spc="100" kern="0" dirty="0">
+              <a:rPr lang="en-US" sz="1000" b="1" spc="100" kern="0" dirty="0">
                 <a:solidFill>
                   <a:srgbClr val="C0392B"/>
                 </a:solidFill>
@@ -19106,9 +19285,9 @@
                 <a:ea typeface="Calibri" pitchFamily="34" charset="-122"/>
                 <a:cs typeface="Calibri" pitchFamily="34" charset="-120"/>
               </a:rPr>
-              <a:t>TOXIC · it</a:t>
-            </a:r>
-            <a:endParaRPr lang="en-US" sz="1100" dirty="0"/>
+              <a:t>TOXIC · en</a:t>
+            </a:r>
+            <a:endParaRPr lang="en-US" sz="1000" dirty="0"/>
           </a:p>
         </p:txBody>
       </p:sp>
@@ -19120,24 +19299,24 @@
         </p:nvSpPr>
         <p:spPr>
           <a:xfrm>
-            <a:off x="6858000" y="4279392"/>
-            <a:ext cx="4572000" cy="685800"/>
-          </a:xfrm>
-          <a:prstGeom prst="rect">
-            <a:avLst/>
-          </a:prstGeom>
-          <a:noFill/>
-          <a:ln/>
-        </p:spPr>
-        <p:txBody>
-          <a:bodyPr wrap="square" rtlCol="0" anchor="ctr"/>
+            <a:off x="6858000" y="2523744"/>
+            <a:ext cx="4572000" cy="402336"/>
+          </a:xfrm>
+          <a:prstGeom prst="rect">
+            <a:avLst/>
+          </a:prstGeom>
+          <a:noFill/>
+          <a:ln/>
+        </p:spPr>
+        <p:txBody>
+          <a:bodyPr wrap="square" rtlCol="0" anchor="t"/>
           <a:lstStyle/>
           <a:p>
             <a:pPr indent="0" marL="0">
               <a:buNone/>
             </a:pPr>
             <a:r>
-              <a:rPr lang="en-US" sz="1250" i="1" dirty="0">
+              <a:rPr lang="en-US" sz="1150" i="1" dirty="0">
                 <a:solidFill>
                   <a:srgbClr val="243044"/>
                 </a:solidFill>
@@ -19145,9 +19324,9 @@
                 <a:ea typeface="Calibri" pitchFamily="34" charset="-122"/>
                 <a:cs typeface="Calibri" pitchFamily="34" charset="-120"/>
               </a:rPr>
-              <a:t>“Incazzato come sei, non sei pure tu un sockpuppet…”</a:t>
-            </a:r>
-            <a:endParaRPr lang="en-US" sz="1250" dirty="0"/>
+              <a:t>“COCKS∗∗∗ER, before you piss around on my work…”</a:t>
+            </a:r>
+            <a:endParaRPr lang="en-US" sz="1150" dirty="0"/>
           </a:p>
         </p:txBody>
       </p:sp>
@@ -19159,12 +19338,12 @@
         </p:nvSpPr>
         <p:spPr>
           <a:xfrm>
-            <a:off x="6629400" y="5120640"/>
-            <a:ext cx="4983480" cy="1078992"/>
+            <a:off x="6629400" y="3063240"/>
+            <a:ext cx="4983480" cy="713232"/>
           </a:xfrm>
           <a:prstGeom prst="roundRect">
             <a:avLst>
-              <a:gd name="adj" fmla="val 5085"/>
+              <a:gd name="adj" fmla="val 7692"/>
             </a:avLst>
           </a:prstGeom>
           <a:solidFill>
@@ -19186,8 +19365,8 @@
         </p:nvSpPr>
         <p:spPr>
           <a:xfrm>
-            <a:off x="6629400" y="5120640"/>
-            <a:ext cx="91440" cy="1078992"/>
+            <a:off x="6629400" y="3063240"/>
+            <a:ext cx="91440" cy="713232"/>
           </a:xfrm>
           <a:prstGeom prst="rect">
             <a:avLst/>
@@ -19206,8 +19385,8 @@
         </p:nvSpPr>
         <p:spPr>
           <a:xfrm>
-            <a:off x="6858000" y="5212080"/>
-            <a:ext cx="4617720" cy="274320"/>
+            <a:off x="6858000" y="3127248"/>
+            <a:ext cx="4617720" cy="219456"/>
           </a:xfrm>
           <a:prstGeom prst="rect">
             <a:avLst/>
@@ -19223,7 +19402,7 @@
               <a:buNone/>
             </a:pPr>
             <a:r>
-              <a:rPr lang="en-US" sz="1100" b="1" spc="100" kern="0" dirty="0">
+              <a:rPr lang="en-US" sz="1000" b="1" spc="100" kern="0" dirty="0">
                 <a:solidFill>
                   <a:srgbClr val="1E8449"/>
                 </a:solidFill>
@@ -19231,9 +19410,9 @@
                 <a:ea typeface="Calibri" pitchFamily="34" charset="-122"/>
                 <a:cs typeface="Calibri" pitchFamily="34" charset="-120"/>
               </a:rPr>
-              <a:t>NON-TOXIC · es</a:t>
-            </a:r>
-            <a:endParaRPr lang="en-US" sz="1100" dirty="0"/>
+              <a:t>NON-TOXIC · tr</a:t>
+            </a:r>
+            <a:endParaRPr lang="en-US" sz="1000" dirty="0"/>
           </a:p>
         </p:txBody>
       </p:sp>
@@ -19245,24 +19424,24 @@
         </p:nvSpPr>
         <p:spPr>
           <a:xfrm>
-            <a:off x="6858000" y="5468112"/>
-            <a:ext cx="4572000" cy="685800"/>
-          </a:xfrm>
-          <a:prstGeom prst="rect">
-            <a:avLst/>
-          </a:prstGeom>
-          <a:noFill/>
-          <a:ln/>
-        </p:spPr>
-        <p:txBody>
-          <a:bodyPr wrap="square" rtlCol="0" anchor="ctr"/>
+            <a:off x="6858000" y="3346704"/>
+            <a:ext cx="4572000" cy="402336"/>
+          </a:xfrm>
+          <a:prstGeom prst="rect">
+            <a:avLst/>
+          </a:prstGeom>
+          <a:noFill/>
+          <a:ln/>
+        </p:spPr>
+        <p:txBody>
+          <a:bodyPr wrap="square" rtlCol="0" anchor="t"/>
           <a:lstStyle/>
           <a:p>
             <a:pPr indent="0" marL="0">
               <a:buNone/>
             </a:pPr>
             <a:r>
-              <a:rPr lang="en-US" sz="1250" i="1" dirty="0">
+              <a:rPr lang="en-US" sz="1150" i="1" dirty="0">
                 <a:solidFill>
                   <a:srgbClr val="243044"/>
                 </a:solidFill>
@@ -19270,46 +19449,421 @@
                 <a:ea typeface="Calibri" pitchFamily="34" charset="-122"/>
                 <a:cs typeface="Calibri" pitchFamily="34" charset="-120"/>
               </a:rPr>
-              <a:t>“Muchas gracias, LlamaAl. Sí que parece útil…”</a:t>
-            </a:r>
-            <a:endParaRPr lang="en-US" sz="1250" dirty="0"/>
-          </a:p>
-        </p:txBody>
-      </p:sp>
-      <p:sp>
-        <p:nvSpPr>
-          <p:cNvPr id="26" name="Text 24"/>
-          <p:cNvSpPr/>
-          <p:nvPr/>
-        </p:nvSpPr>
-        <p:spPr>
-          <a:xfrm>
-            <a:off x="6629400" y="6355080"/>
-            <a:ext cx="4937760" cy="274320"/>
-          </a:xfrm>
-          <a:prstGeom prst="rect">
-            <a:avLst/>
-          </a:prstGeom>
-          <a:noFill/>
-          <a:ln/>
-        </p:spPr>
-        <p:txBody>
-          <a:bodyPr wrap="square" rtlCol="0" anchor="ctr"/>
-          <a:lstStyle/>
-          <a:p>
-            <a:pPr algn="r" indent="0" marL="0">
-              <a:buNone/>
-            </a:pPr>
-            <a:r>
-              <a:rPr lang="en-US" sz="900" i="1" dirty="0">
-                <a:solidFill>
-                  <a:srgbClr val="6B7480"/>
+              <a:t>“Eline sağlık, açıklaman çok işime yaradı, teşekkürler!”</a:t>
+            </a:r>
+            <a:endParaRPr lang="en-US" sz="1150" dirty="0"/>
+          </a:p>
+        </p:txBody>
+      </p:sp>
+      <p:sp>
+        <p:nvSpPr>
+          <p:cNvPr id="26" name="Shape 24"/>
+          <p:cNvSpPr/>
+          <p:nvPr/>
+        </p:nvSpPr>
+        <p:spPr>
+          <a:xfrm>
+            <a:off x="6629400" y="3886200"/>
+            <a:ext cx="4983480" cy="713232"/>
+          </a:xfrm>
+          <a:prstGeom prst="roundRect">
+            <a:avLst>
+              <a:gd name="adj" fmla="val 7692"/>
+            </a:avLst>
+          </a:prstGeom>
+          <a:solidFill>
+            <a:srgbClr val="FFFFFF"/>
+          </a:solidFill>
+          <a:ln w="12700">
+            <a:solidFill>
+              <a:srgbClr val="E2E8F0"/>
+            </a:solidFill>
+            <a:prstDash val="solid"/>
+          </a:ln>
+        </p:spPr>
+      </p:sp>
+      <p:sp>
+        <p:nvSpPr>
+          <p:cNvPr id="27" name="Shape 25"/>
+          <p:cNvSpPr/>
+          <p:nvPr/>
+        </p:nvSpPr>
+        <p:spPr>
+          <a:xfrm>
+            <a:off x="6629400" y="3886200"/>
+            <a:ext cx="91440" cy="713232"/>
+          </a:xfrm>
+          <a:prstGeom prst="rect">
+            <a:avLst/>
+          </a:prstGeom>
+          <a:solidFill>
+            <a:srgbClr val="C0392B"/>
+          </a:solidFill>
+          <a:ln/>
+        </p:spPr>
+      </p:sp>
+      <p:sp>
+        <p:nvSpPr>
+          <p:cNvPr id="28" name="Text 26"/>
+          <p:cNvSpPr/>
+          <p:nvPr/>
+        </p:nvSpPr>
+        <p:spPr>
+          <a:xfrm>
+            <a:off x="6858000" y="3950208"/>
+            <a:ext cx="4617720" cy="219456"/>
+          </a:xfrm>
+          <a:prstGeom prst="rect">
+            <a:avLst/>
+          </a:prstGeom>
+          <a:noFill/>
+          <a:ln/>
+        </p:spPr>
+        <p:txBody>
+          <a:bodyPr wrap="square" rtlCol="0" anchor="ctr"/>
+          <a:lstStyle/>
+          <a:p>
+            <a:pPr indent="0" marL="0">
+              <a:buNone/>
+            </a:pPr>
+            <a:r>
+              <a:rPr lang="en-US" sz="1000" b="1" spc="100" kern="0" dirty="0">
+                <a:solidFill>
+                  <a:srgbClr val="C0392B"/>
                 </a:solidFill>
                 <a:latin typeface="Calibri" pitchFamily="34" charset="0"/>
                 <a:ea typeface="Calibri" pitchFamily="34" charset="-122"/>
                 <a:cs typeface="Calibri" pitchFamily="34" charset="-120"/>
               </a:rPr>
-              <a:t>Examples shortened / lightly censored for the slide.</a:t>
+              <a:t>TOXIC · tr</a:t>
+            </a:r>
+            <a:endParaRPr lang="en-US" sz="1000" dirty="0"/>
+          </a:p>
+        </p:txBody>
+      </p:sp>
+      <p:sp>
+        <p:nvSpPr>
+          <p:cNvPr id="29" name="Text 27"/>
+          <p:cNvSpPr/>
+          <p:nvPr/>
+        </p:nvSpPr>
+        <p:spPr>
+          <a:xfrm>
+            <a:off x="6858000" y="4169664"/>
+            <a:ext cx="4572000" cy="402336"/>
+          </a:xfrm>
+          <a:prstGeom prst="rect">
+            <a:avLst/>
+          </a:prstGeom>
+          <a:noFill/>
+          <a:ln/>
+        </p:spPr>
+        <p:txBody>
+          <a:bodyPr wrap="square" rtlCol="0" anchor="t"/>
+          <a:lstStyle/>
+          <a:p>
+            <a:pPr indent="0" marL="0">
+              <a:buNone/>
+            </a:pPr>
+            <a:r>
+              <a:rPr lang="en-US" sz="1150" i="1" dirty="0">
+                <a:solidFill>
+                  <a:srgbClr val="243044"/>
+                </a:solidFill>
+                <a:latin typeface="Calibri" pitchFamily="34" charset="0"/>
+                <a:ea typeface="Calibri" pitchFamily="34" charset="-122"/>
+                <a:cs typeface="Calibri" pitchFamily="34" charset="-120"/>
+              </a:rPr>
+              <a:t>“Aptal herif, s∗∗tir git buradan.”</a:t>
+            </a:r>
+            <a:endParaRPr lang="en-US" sz="1150" dirty="0"/>
+          </a:p>
+        </p:txBody>
+      </p:sp>
+      <p:sp>
+        <p:nvSpPr>
+          <p:cNvPr id="30" name="Shape 28"/>
+          <p:cNvSpPr/>
+          <p:nvPr/>
+        </p:nvSpPr>
+        <p:spPr>
+          <a:xfrm>
+            <a:off x="6629400" y="4709160"/>
+            <a:ext cx="4983480" cy="713232"/>
+          </a:xfrm>
+          <a:prstGeom prst="roundRect">
+            <a:avLst>
+              <a:gd name="adj" fmla="val 7692"/>
+            </a:avLst>
+          </a:prstGeom>
+          <a:solidFill>
+            <a:srgbClr val="FFFFFF"/>
+          </a:solidFill>
+          <a:ln w="12700">
+            <a:solidFill>
+              <a:srgbClr val="E2E8F0"/>
+            </a:solidFill>
+            <a:prstDash val="solid"/>
+          </a:ln>
+        </p:spPr>
+      </p:sp>
+      <p:sp>
+        <p:nvSpPr>
+          <p:cNvPr id="31" name="Shape 29"/>
+          <p:cNvSpPr/>
+          <p:nvPr/>
+        </p:nvSpPr>
+        <p:spPr>
+          <a:xfrm>
+            <a:off x="6629400" y="4709160"/>
+            <a:ext cx="91440" cy="713232"/>
+          </a:xfrm>
+          <a:prstGeom prst="rect">
+            <a:avLst/>
+          </a:prstGeom>
+          <a:solidFill>
+            <a:srgbClr val="1E8449"/>
+          </a:solidFill>
+          <a:ln/>
+        </p:spPr>
+      </p:sp>
+      <p:sp>
+        <p:nvSpPr>
+          <p:cNvPr id="32" name="Text 30"/>
+          <p:cNvSpPr/>
+          <p:nvPr/>
+        </p:nvSpPr>
+        <p:spPr>
+          <a:xfrm>
+            <a:off x="6858000" y="4773168"/>
+            <a:ext cx="4617720" cy="219456"/>
+          </a:xfrm>
+          <a:prstGeom prst="rect">
+            <a:avLst/>
+          </a:prstGeom>
+          <a:noFill/>
+          <a:ln/>
+        </p:spPr>
+        <p:txBody>
+          <a:bodyPr wrap="square" rtlCol="0" anchor="ctr"/>
+          <a:lstStyle/>
+          <a:p>
+            <a:pPr indent="0" marL="0">
+              <a:buNone/>
+            </a:pPr>
+            <a:r>
+              <a:rPr lang="en-US" sz="1000" b="1" spc="100" kern="0" dirty="0">
+                <a:solidFill>
+                  <a:srgbClr val="1E8449"/>
+                </a:solidFill>
+                <a:latin typeface="Calibri" pitchFamily="34" charset="0"/>
+                <a:ea typeface="Calibri" pitchFamily="34" charset="-122"/>
+                <a:cs typeface="Calibri" pitchFamily="34" charset="-120"/>
+              </a:rPr>
+              <a:t>NON-TOXIC · es</a:t>
+            </a:r>
+            <a:endParaRPr lang="en-US" sz="1000" dirty="0"/>
+          </a:p>
+        </p:txBody>
+      </p:sp>
+      <p:sp>
+        <p:nvSpPr>
+          <p:cNvPr id="33" name="Text 31"/>
+          <p:cNvSpPr/>
+          <p:nvPr/>
+        </p:nvSpPr>
+        <p:spPr>
+          <a:xfrm>
+            <a:off x="6858000" y="4992624"/>
+            <a:ext cx="4572000" cy="402336"/>
+          </a:xfrm>
+          <a:prstGeom prst="rect">
+            <a:avLst/>
+          </a:prstGeom>
+          <a:noFill/>
+          <a:ln/>
+        </p:spPr>
+        <p:txBody>
+          <a:bodyPr wrap="square" rtlCol="0" anchor="t"/>
+          <a:lstStyle/>
+          <a:p>
+            <a:pPr indent="0" marL="0">
+              <a:buNone/>
+            </a:pPr>
+            <a:r>
+              <a:rPr lang="en-US" sz="1150" i="1" dirty="0">
+                <a:solidFill>
+                  <a:srgbClr val="243044"/>
+                </a:solidFill>
+                <a:latin typeface="Calibri" pitchFamily="34" charset="0"/>
+                <a:ea typeface="Calibri" pitchFamily="34" charset="-122"/>
+                <a:cs typeface="Calibri" pitchFamily="34" charset="-120"/>
+              </a:rPr>
+              <a:t>“Muchas gracias, LlamaAl. Sí que parece útil…”</a:t>
+            </a:r>
+            <a:endParaRPr lang="en-US" sz="1150" dirty="0"/>
+          </a:p>
+        </p:txBody>
+      </p:sp>
+      <p:sp>
+        <p:nvSpPr>
+          <p:cNvPr id="34" name="Shape 32"/>
+          <p:cNvSpPr/>
+          <p:nvPr/>
+        </p:nvSpPr>
+        <p:spPr>
+          <a:xfrm>
+            <a:off x="6629400" y="5532120"/>
+            <a:ext cx="4983480" cy="713232"/>
+          </a:xfrm>
+          <a:prstGeom prst="roundRect">
+            <a:avLst>
+              <a:gd name="adj" fmla="val 7692"/>
+            </a:avLst>
+          </a:prstGeom>
+          <a:solidFill>
+            <a:srgbClr val="FFFFFF"/>
+          </a:solidFill>
+          <a:ln w="12700">
+            <a:solidFill>
+              <a:srgbClr val="E2E8F0"/>
+            </a:solidFill>
+            <a:prstDash val="solid"/>
+          </a:ln>
+        </p:spPr>
+      </p:sp>
+      <p:sp>
+        <p:nvSpPr>
+          <p:cNvPr id="35" name="Shape 33"/>
+          <p:cNvSpPr/>
+          <p:nvPr/>
+        </p:nvSpPr>
+        <p:spPr>
+          <a:xfrm>
+            <a:off x="6629400" y="5532120"/>
+            <a:ext cx="91440" cy="713232"/>
+          </a:xfrm>
+          <a:prstGeom prst="rect">
+            <a:avLst/>
+          </a:prstGeom>
+          <a:solidFill>
+            <a:srgbClr val="C0392B"/>
+          </a:solidFill>
+          <a:ln/>
+        </p:spPr>
+      </p:sp>
+      <p:sp>
+        <p:nvSpPr>
+          <p:cNvPr id="36" name="Text 34"/>
+          <p:cNvSpPr/>
+          <p:nvPr/>
+        </p:nvSpPr>
+        <p:spPr>
+          <a:xfrm>
+            <a:off x="6858000" y="5596128"/>
+            <a:ext cx="4617720" cy="219456"/>
+          </a:xfrm>
+          <a:prstGeom prst="rect">
+            <a:avLst/>
+          </a:prstGeom>
+          <a:noFill/>
+          <a:ln/>
+        </p:spPr>
+        <p:txBody>
+          <a:bodyPr wrap="square" rtlCol="0" anchor="ctr"/>
+          <a:lstStyle/>
+          <a:p>
+            <a:pPr indent="0" marL="0">
+              <a:buNone/>
+            </a:pPr>
+            <a:r>
+              <a:rPr lang="en-US" sz="1000" b="1" spc="100" kern="0" dirty="0">
+                <a:solidFill>
+                  <a:srgbClr val="C0392B"/>
+                </a:solidFill>
+                <a:latin typeface="Calibri" pitchFamily="34" charset="0"/>
+                <a:ea typeface="Calibri" pitchFamily="34" charset="-122"/>
+                <a:cs typeface="Calibri" pitchFamily="34" charset="-120"/>
+              </a:rPr>
+              <a:t>TOXIC · it</a:t>
+            </a:r>
+            <a:endParaRPr lang="en-US" sz="1000" dirty="0"/>
+          </a:p>
+        </p:txBody>
+      </p:sp>
+      <p:sp>
+        <p:nvSpPr>
+          <p:cNvPr id="37" name="Text 35"/>
+          <p:cNvSpPr/>
+          <p:nvPr/>
+        </p:nvSpPr>
+        <p:spPr>
+          <a:xfrm>
+            <a:off x="6858000" y="5815584"/>
+            <a:ext cx="4572000" cy="402336"/>
+          </a:xfrm>
+          <a:prstGeom prst="rect">
+            <a:avLst/>
+          </a:prstGeom>
+          <a:noFill/>
+          <a:ln/>
+        </p:spPr>
+        <p:txBody>
+          <a:bodyPr wrap="square" rtlCol="0" anchor="t"/>
+          <a:lstStyle/>
+          <a:p>
+            <a:pPr indent="0" marL="0">
+              <a:buNone/>
+            </a:pPr>
+            <a:r>
+              <a:rPr lang="en-US" sz="1150" i="1" dirty="0">
+                <a:solidFill>
+                  <a:srgbClr val="243044"/>
+                </a:solidFill>
+                <a:latin typeface="Calibri" pitchFamily="34" charset="0"/>
+                <a:ea typeface="Calibri" pitchFamily="34" charset="-122"/>
+                <a:cs typeface="Calibri" pitchFamily="34" charset="-120"/>
+              </a:rPr>
+              <a:t>“Incazzato come sei, non sei pure tu un sockpuppet…”</a:t>
+            </a:r>
+            <a:endParaRPr lang="en-US" sz="1150" dirty="0"/>
+          </a:p>
+        </p:txBody>
+      </p:sp>
+      <p:sp>
+        <p:nvSpPr>
+          <p:cNvPr id="38" name="Text 36"/>
+          <p:cNvSpPr/>
+          <p:nvPr/>
+        </p:nvSpPr>
+        <p:spPr>
+          <a:xfrm>
+            <a:off x="6629400" y="6355080"/>
+            <a:ext cx="4937760" cy="274320"/>
+          </a:xfrm>
+          <a:prstGeom prst="rect">
+            <a:avLst/>
+          </a:prstGeom>
+          <a:noFill/>
+          <a:ln/>
+        </p:spPr>
+        <p:txBody>
+          <a:bodyPr wrap="square" rtlCol="0" anchor="ctr"/>
+          <a:lstStyle/>
+          <a:p>
+            <a:pPr algn="r" indent="0" marL="0">
+              <a:buNone/>
+            </a:pPr>
+            <a:r>
+              <a:rPr lang="en-US" sz="900" i="1" dirty="0">
+                <a:solidFill>
+                  <a:srgbClr val="6B7480"/>
+                </a:solidFill>
+                <a:latin typeface="Calibri" pitchFamily="34" charset="0"/>
+                <a:ea typeface="Calibri" pitchFamily="34" charset="-122"/>
+                <a:cs typeface="Calibri" pitchFamily="34" charset="-120"/>
+              </a:rPr>
+              <a:t>Examples shortened / censored for the slide.</a:t>
             </a:r>
             <a:endParaRPr lang="en-US" sz="900" dirty="0"/>
           </a:p>

</xml_diff>